<commit_message>
Slider- Show data in index page
</commit_message>
<xml_diff>
--- a/.lessons/54 Slider Features/6 Slider- Show data in index page/1.pptx
+++ b/.lessons/54 Slider Features/6 Slider- Show data in index page/1.pptx
@@ -7,7 +7,12 @@
   <p:sldIdLst>
     <p:sldId id="413" r:id="rId2"/>
     <p:sldId id="414" r:id="rId3"/>
-    <p:sldId id="400" r:id="rId4"/>
+    <p:sldId id="415" r:id="rId4"/>
+    <p:sldId id="416" r:id="rId5"/>
+    <p:sldId id="417" r:id="rId6"/>
+    <p:sldId id="418" r:id="rId7"/>
+    <p:sldId id="419" r:id="rId8"/>
+    <p:sldId id="400" r:id="rId9"/>
   </p:sldIdLst>
   <p:sldSz cx="12192000" cy="6858000"/>
   <p:notesSz cx="6858000" cy="9144000"/>
@@ -261,7 +266,7 @@
           <a:p>
             <a:fld id="{3E102D2E-813C-461C-9963-687A650C48C0}" type="datetimeFigureOut">
               <a:rPr lang="en-US" smtClean="0"/>
-              <a:t>6/26/2025</a:t>
+              <a:t>8/7/2025</a:t>
             </a:fld>
             <a:endParaRPr lang="en-US"/>
           </a:p>
@@ -459,7 +464,7 @@
           <a:p>
             <a:fld id="{3E102D2E-813C-461C-9963-687A650C48C0}" type="datetimeFigureOut">
               <a:rPr lang="en-US" smtClean="0"/>
-              <a:t>6/26/2025</a:t>
+              <a:t>8/7/2025</a:t>
             </a:fld>
             <a:endParaRPr lang="en-US"/>
           </a:p>
@@ -667,7 +672,7 @@
           <a:p>
             <a:fld id="{3E102D2E-813C-461C-9963-687A650C48C0}" type="datetimeFigureOut">
               <a:rPr lang="en-US" smtClean="0"/>
-              <a:t>6/26/2025</a:t>
+              <a:t>8/7/2025</a:t>
             </a:fld>
             <a:endParaRPr lang="en-US"/>
           </a:p>
@@ -865,7 +870,7 @@
           <a:p>
             <a:fld id="{3E102D2E-813C-461C-9963-687A650C48C0}" type="datetimeFigureOut">
               <a:rPr lang="en-US" smtClean="0"/>
-              <a:t>6/26/2025</a:t>
+              <a:t>8/7/2025</a:t>
             </a:fld>
             <a:endParaRPr lang="en-US"/>
           </a:p>
@@ -1140,7 +1145,7 @@
           <a:p>
             <a:fld id="{3E102D2E-813C-461C-9963-687A650C48C0}" type="datetimeFigureOut">
               <a:rPr lang="en-US" smtClean="0"/>
-              <a:t>6/26/2025</a:t>
+              <a:t>8/7/2025</a:t>
             </a:fld>
             <a:endParaRPr lang="en-US"/>
           </a:p>
@@ -1405,7 +1410,7 @@
           <a:p>
             <a:fld id="{3E102D2E-813C-461C-9963-687A650C48C0}" type="datetimeFigureOut">
               <a:rPr lang="en-US" smtClean="0"/>
-              <a:t>6/26/2025</a:t>
+              <a:t>8/7/2025</a:t>
             </a:fld>
             <a:endParaRPr lang="en-US"/>
           </a:p>
@@ -1817,7 +1822,7 @@
           <a:p>
             <a:fld id="{3E102D2E-813C-461C-9963-687A650C48C0}" type="datetimeFigureOut">
               <a:rPr lang="en-US" smtClean="0"/>
-              <a:t>6/26/2025</a:t>
+              <a:t>8/7/2025</a:t>
             </a:fld>
             <a:endParaRPr lang="en-US"/>
           </a:p>
@@ -1958,7 +1963,7 @@
           <a:p>
             <a:fld id="{3E102D2E-813C-461C-9963-687A650C48C0}" type="datetimeFigureOut">
               <a:rPr lang="en-US" smtClean="0"/>
-              <a:t>6/26/2025</a:t>
+              <a:t>8/7/2025</a:t>
             </a:fld>
             <a:endParaRPr lang="en-US"/>
           </a:p>
@@ -2071,7 +2076,7 @@
           <a:p>
             <a:fld id="{3E102D2E-813C-461C-9963-687A650C48C0}" type="datetimeFigureOut">
               <a:rPr lang="en-US" smtClean="0"/>
-              <a:t>6/26/2025</a:t>
+              <a:t>8/7/2025</a:t>
             </a:fld>
             <a:endParaRPr lang="en-US"/>
           </a:p>
@@ -2382,7 +2387,7 @@
           <a:p>
             <a:fld id="{3E102D2E-813C-461C-9963-687A650C48C0}" type="datetimeFigureOut">
               <a:rPr lang="en-US" smtClean="0"/>
-              <a:t>6/26/2025</a:t>
+              <a:t>8/7/2025</a:t>
             </a:fld>
             <a:endParaRPr lang="en-US"/>
           </a:p>
@@ -2670,7 +2675,7 @@
           <a:p>
             <a:fld id="{3E102D2E-813C-461C-9963-687A650C48C0}" type="datetimeFigureOut">
               <a:rPr lang="en-US" smtClean="0"/>
-              <a:t>6/26/2025</a:t>
+              <a:t>8/7/2025</a:t>
             </a:fld>
             <a:endParaRPr lang="en-US"/>
           </a:p>
@@ -2911,7 +2916,7 @@
           <a:p>
             <a:fld id="{3E102D2E-813C-461C-9963-687A650C48C0}" type="datetimeFigureOut">
               <a:rPr lang="en-US" smtClean="0"/>
-              <a:t>6/26/2025</a:t>
+              <a:t>8/7/2025</a:t>
             </a:fld>
             <a:endParaRPr lang="en-US"/>
           </a:p>
@@ -3349,7 +3354,7 @@
         <p:spPr>
           <a:xfrm>
             <a:off x="217714" y="255046"/>
-            <a:ext cx="11756571" cy="355354"/>
+            <a:ext cx="11756571" cy="655436"/>
           </a:xfrm>
           <a:prstGeom prst="rect">
             <a:avLst/>
@@ -3369,21 +3374,98 @@
               <a:buNone/>
             </a:pPr>
             <a:r>
-              <a:rPr kumimoji="0" lang="en-US" altLang="en-US" sz="1300" b="0" i="0" u="none" strike="noStrike" cap="none" normalizeH="0" baseline="0">
-                <a:ln>
-                  <a:noFill/>
-                </a:ln>
-                <a:solidFill>
-                  <a:schemeClr val="tx1"/>
-                </a:solidFill>
-                <a:effectLst/>
+              <a:rPr lang="az-Latn-AZ" altLang="en-US" sz="1300">
                 <a:latin typeface="Arial" panose="020B0604020202020204" pitchFamily="34" charset="0"/>
               </a:rPr>
-              <a:t>.</a:t>
-            </a:r>
-          </a:p>
-        </p:txBody>
-      </p:sp>
+              <a:t>Tərtib olunan cədvəldə lazımsız </a:t>
+            </a:r>
+            <a:r>
+              <a:rPr lang="az-Latn-AZ" altLang="en-US" sz="1300" b="1">
+                <a:latin typeface="Arial" panose="020B0604020202020204" pitchFamily="34" charset="0"/>
+              </a:rPr>
+              <a:t>sütun</a:t>
+            </a:r>
+            <a:r>
+              <a:rPr lang="az-Latn-AZ" altLang="en-US" sz="1300">
+                <a:latin typeface="Arial" panose="020B0604020202020204" pitchFamily="34" charset="0"/>
+              </a:rPr>
+              <a:t> adları var. Bunları konfiqurasiya etmək üçün isə, `</a:t>
+            </a:r>
+            <a:r>
+              <a:rPr lang="az-Latn-AZ" altLang="en-US" sz="1300" b="1">
+                <a:latin typeface="Arial" panose="020B0604020202020204" pitchFamily="34" charset="0"/>
+              </a:rPr>
+              <a:t>app\DataTables\</a:t>
+            </a:r>
+            <a:r>
+              <a:rPr lang="az-Latn-AZ" altLang="en-US" sz="1300" b="1" u="sng">
+                <a:latin typeface="Arial" panose="020B0604020202020204" pitchFamily="34" charset="0"/>
+              </a:rPr>
+              <a:t>SliderDataTable.php</a:t>
+            </a:r>
+            <a:r>
+              <a:rPr lang="az-Latn-AZ" altLang="en-US" sz="1300">
+                <a:latin typeface="Arial" panose="020B0604020202020204" pitchFamily="34" charset="0"/>
+              </a:rPr>
+              <a:t>` faylına müdaxilə etmək lazımdır.</a:t>
+            </a:r>
+            <a:endParaRPr kumimoji="0" lang="en-US" altLang="en-US" sz="1300" b="0" i="0" u="none" strike="noStrike" cap="none" normalizeH="0" baseline="0">
+              <a:ln>
+                <a:noFill/>
+              </a:ln>
+              <a:solidFill>
+                <a:schemeClr val="tx1"/>
+              </a:solidFill>
+              <a:effectLst/>
+              <a:latin typeface="Arial" panose="020B0604020202020204" pitchFamily="34" charset="0"/>
+            </a:endParaRPr>
+          </a:p>
+        </p:txBody>
+      </p:sp>
+      <p:pic>
+        <p:nvPicPr>
+          <p:cNvPr id="4" name="Picture 3">
+            <a:extLst>
+              <a:ext uri="{FF2B5EF4-FFF2-40B4-BE49-F238E27FC236}">
+                <a16:creationId xmlns:a16="http://schemas.microsoft.com/office/drawing/2014/main" id="{AE1C954C-4407-80F2-0AFC-011D0DE38088}"/>
+              </a:ext>
+            </a:extLst>
+          </p:cNvPr>
+          <p:cNvPicPr>
+            <a:picLocks noChangeAspect="1"/>
+          </p:cNvPicPr>
+          <p:nvPr/>
+        </p:nvPicPr>
+        <p:blipFill>
+          <a:blip r:embed="rId2"/>
+          <a:stretch>
+            <a:fillRect/>
+          </a:stretch>
+        </p:blipFill>
+        <p:spPr>
+          <a:xfrm>
+            <a:off x="0" y="2757980"/>
+            <a:ext cx="12192000" cy="4100020"/>
+          </a:xfrm>
+          <a:prstGeom prst="rect">
+            <a:avLst/>
+          </a:prstGeom>
+          <a:ln w="38100" cap="sq">
+            <a:solidFill>
+              <a:srgbClr val="000000"/>
+            </a:solidFill>
+            <a:prstDash val="solid"/>
+            <a:miter lim="800000"/>
+          </a:ln>
+          <a:effectLst>
+            <a:outerShdw blurRad="50800" dist="38100" dir="2700000" algn="tl" rotWithShape="0">
+              <a:srgbClr val="000000">
+                <a:alpha val="43000"/>
+              </a:srgbClr>
+            </a:outerShdw>
+          </a:effectLst>
+        </p:spPr>
+      </p:pic>
     </p:spTree>
     <p:extLst>
       <p:ext uri="{BB962C8B-B14F-4D97-AF65-F5344CB8AC3E}">
@@ -3455,21 +3537,54 @@
               <a:buNone/>
             </a:pPr>
             <a:r>
-              <a:rPr kumimoji="0" lang="en-US" altLang="en-US" sz="1300" b="0" i="0" u="none" strike="noStrike" cap="none" normalizeH="0" baseline="0">
-                <a:ln>
-                  <a:noFill/>
-                </a:ln>
-                <a:solidFill>
-                  <a:schemeClr val="tx1"/>
-                </a:solidFill>
-                <a:effectLst/>
+              <a:rPr lang="az-Latn-AZ" altLang="en-US" sz="1300">
                 <a:latin typeface="Arial" panose="020B0604020202020204" pitchFamily="34" charset="0"/>
               </a:rPr>
-              <a:t>.</a:t>
-            </a:r>
-          </a:p>
-        </p:txBody>
-      </p:sp>
+              <a:t>Belə bir konfiqurasiya edirik. </a:t>
+            </a:r>
+            <a:endParaRPr kumimoji="0" lang="en-US" altLang="en-US" sz="1300" b="0" i="0" u="none" strike="noStrike" cap="none" normalizeH="0" baseline="0">
+              <a:ln>
+                <a:noFill/>
+              </a:ln>
+              <a:solidFill>
+                <a:schemeClr val="tx1"/>
+              </a:solidFill>
+              <a:effectLst/>
+              <a:latin typeface="Arial" panose="020B0604020202020204" pitchFamily="34" charset="0"/>
+            </a:endParaRPr>
+          </a:p>
+        </p:txBody>
+      </p:sp>
+      <p:pic>
+        <p:nvPicPr>
+          <p:cNvPr id="4" name="Picture 3">
+            <a:extLst>
+              <a:ext uri="{FF2B5EF4-FFF2-40B4-BE49-F238E27FC236}">
+                <a16:creationId xmlns:a16="http://schemas.microsoft.com/office/drawing/2014/main" id="{A1387686-86ED-6571-D198-113379FA262B}"/>
+              </a:ext>
+            </a:extLst>
+          </p:cNvPr>
+          <p:cNvPicPr>
+            <a:picLocks noChangeAspect="1"/>
+          </p:cNvPicPr>
+          <p:nvPr/>
+        </p:nvPicPr>
+        <p:blipFill>
+          <a:blip r:embed="rId2"/>
+          <a:stretch>
+            <a:fillRect/>
+          </a:stretch>
+        </p:blipFill>
+        <p:spPr>
+          <a:xfrm>
+            <a:off x="5362164" y="0"/>
+            <a:ext cx="6829836" cy="6858000"/>
+          </a:xfrm>
+          <a:prstGeom prst="rect">
+            <a:avLst/>
+          </a:prstGeom>
+        </p:spPr>
+      </p:pic>
     </p:spTree>
     <p:extLst>
       <p:ext uri="{BB962C8B-B14F-4D97-AF65-F5344CB8AC3E}">
@@ -3484,6 +3599,661 @@
 </file>
 
 <file path=ppt/slides/slide3.xml><?xml version="1.0" encoding="utf-8"?>
+<p:sld xmlns:a="http://schemas.openxmlformats.org/drawingml/2006/main" xmlns:r="http://schemas.openxmlformats.org/officeDocument/2006/relationships" xmlns:p="http://schemas.openxmlformats.org/presentationml/2006/main">
+  <p:cSld>
+    <p:spTree>
+      <p:nvGrpSpPr>
+        <p:cNvPr id="1" name="">
+          <a:extLst>
+            <a:ext uri="{FF2B5EF4-FFF2-40B4-BE49-F238E27FC236}">
+              <a16:creationId xmlns:a16="http://schemas.microsoft.com/office/drawing/2014/main" id="{DBB1970D-ACB7-776D-E252-30E41C03987E}"/>
+            </a:ext>
+          </a:extLst>
+        </p:cNvPr>
+        <p:cNvGrpSpPr/>
+        <p:nvPr/>
+      </p:nvGrpSpPr>
+      <p:grpSpPr>
+        <a:xfrm>
+          <a:off x="0" y="0"/>
+          <a:ext cx="0" cy="0"/>
+          <a:chOff x="0" y="0"/>
+          <a:chExt cx="0" cy="0"/>
+        </a:xfrm>
+      </p:grpSpPr>
+      <p:sp>
+        <p:nvSpPr>
+          <p:cNvPr id="3" name="TextBox 2">
+            <a:extLst>
+              <a:ext uri="{FF2B5EF4-FFF2-40B4-BE49-F238E27FC236}">
+                <a16:creationId xmlns:a16="http://schemas.microsoft.com/office/drawing/2014/main" id="{C2409D28-0A0D-C0B6-9EF1-3E399CC38225}"/>
+              </a:ext>
+            </a:extLst>
+          </p:cNvPr>
+          <p:cNvSpPr txBox="1"/>
+          <p:nvPr/>
+        </p:nvSpPr>
+        <p:spPr>
+          <a:xfrm>
+            <a:off x="217714" y="255046"/>
+            <a:ext cx="11756571" cy="355354"/>
+          </a:xfrm>
+          <a:prstGeom prst="rect">
+            <a:avLst/>
+          </a:prstGeom>
+          <a:noFill/>
+        </p:spPr>
+        <p:txBody>
+          <a:bodyPr wrap="square">
+            <a:spAutoFit/>
+          </a:bodyPr>
+          <a:lstStyle/>
+          <a:p>
+            <a:pPr>
+              <a:lnSpc>
+                <a:spcPct val="150000"/>
+              </a:lnSpc>
+              <a:buNone/>
+            </a:pPr>
+            <a:r>
+              <a:rPr kumimoji="0" lang="az-Latn-AZ" altLang="en-US" sz="1300" b="0" i="0" u="none" strike="noStrike" cap="none" normalizeH="0" baseline="0">
+                <a:ln>
+                  <a:noFill/>
+                </a:ln>
+                <a:solidFill>
+                  <a:schemeClr val="tx1"/>
+                </a:solidFill>
+                <a:effectLst/>
+                <a:latin typeface="Arial" panose="020B0604020202020204" pitchFamily="34" charset="0"/>
+              </a:rPr>
+              <a:t>Və belə bir nəticə əldə edirik.</a:t>
+            </a:r>
+            <a:endParaRPr kumimoji="0" lang="en-US" altLang="en-US" sz="1300" b="0" i="0" u="none" strike="noStrike" cap="none" normalizeH="0" baseline="0">
+              <a:ln>
+                <a:noFill/>
+              </a:ln>
+              <a:solidFill>
+                <a:schemeClr val="tx1"/>
+              </a:solidFill>
+              <a:effectLst/>
+              <a:latin typeface="Arial" panose="020B0604020202020204" pitchFamily="34" charset="0"/>
+            </a:endParaRPr>
+          </a:p>
+        </p:txBody>
+      </p:sp>
+      <p:pic>
+        <p:nvPicPr>
+          <p:cNvPr id="4" name="Picture 3">
+            <a:extLst>
+              <a:ext uri="{FF2B5EF4-FFF2-40B4-BE49-F238E27FC236}">
+                <a16:creationId xmlns:a16="http://schemas.microsoft.com/office/drawing/2014/main" id="{6ACE79BA-C8E2-4515-338E-41AAC7126CC0}"/>
+              </a:ext>
+            </a:extLst>
+          </p:cNvPr>
+          <p:cNvPicPr>
+            <a:picLocks noChangeAspect="1"/>
+          </p:cNvPicPr>
+          <p:nvPr/>
+        </p:nvPicPr>
+        <p:blipFill>
+          <a:blip r:embed="rId2"/>
+          <a:stretch>
+            <a:fillRect/>
+          </a:stretch>
+        </p:blipFill>
+        <p:spPr>
+          <a:xfrm>
+            <a:off x="0" y="1379236"/>
+            <a:ext cx="12192000" cy="5478764"/>
+          </a:xfrm>
+          <a:prstGeom prst="rect">
+            <a:avLst/>
+          </a:prstGeom>
+          <a:ln w="38100" cap="sq">
+            <a:solidFill>
+              <a:srgbClr val="000000"/>
+            </a:solidFill>
+            <a:prstDash val="solid"/>
+            <a:miter lim="800000"/>
+          </a:ln>
+          <a:effectLst>
+            <a:outerShdw blurRad="50800" dist="38100" dir="2700000" algn="tl" rotWithShape="0">
+              <a:srgbClr val="000000">
+                <a:alpha val="43000"/>
+              </a:srgbClr>
+            </a:outerShdw>
+          </a:effectLst>
+        </p:spPr>
+      </p:pic>
+    </p:spTree>
+    <p:extLst>
+      <p:ext uri="{BB962C8B-B14F-4D97-AF65-F5344CB8AC3E}">
+        <p14:creationId xmlns:p14="http://schemas.microsoft.com/office/powerpoint/2010/main" val="3540265918"/>
+      </p:ext>
+    </p:extLst>
+  </p:cSld>
+  <p:clrMapOvr>
+    <a:masterClrMapping/>
+  </p:clrMapOvr>
+</p:sld>
+</file>
+
+<file path=ppt/slides/slide4.xml><?xml version="1.0" encoding="utf-8"?>
+<p:sld xmlns:a="http://schemas.openxmlformats.org/drawingml/2006/main" xmlns:r="http://schemas.openxmlformats.org/officeDocument/2006/relationships" xmlns:p="http://schemas.openxmlformats.org/presentationml/2006/main">
+  <p:cSld>
+    <p:spTree>
+      <p:nvGrpSpPr>
+        <p:cNvPr id="1" name="">
+          <a:extLst>
+            <a:ext uri="{FF2B5EF4-FFF2-40B4-BE49-F238E27FC236}">
+              <a16:creationId xmlns:a16="http://schemas.microsoft.com/office/drawing/2014/main" id="{8CD688A1-831F-69FB-EE77-A67AD7893FFE}"/>
+            </a:ext>
+          </a:extLst>
+        </p:cNvPr>
+        <p:cNvGrpSpPr/>
+        <p:nvPr/>
+      </p:nvGrpSpPr>
+      <p:grpSpPr>
+        <a:xfrm>
+          <a:off x="0" y="0"/>
+          <a:ext cx="0" cy="0"/>
+          <a:chOff x="0" y="0"/>
+          <a:chExt cx="0" cy="0"/>
+        </a:xfrm>
+      </p:grpSpPr>
+      <p:sp>
+        <p:nvSpPr>
+          <p:cNvPr id="3" name="TextBox 2">
+            <a:extLst>
+              <a:ext uri="{FF2B5EF4-FFF2-40B4-BE49-F238E27FC236}">
+                <a16:creationId xmlns:a16="http://schemas.microsoft.com/office/drawing/2014/main" id="{46D59B1D-043F-23A7-504C-82C6869FFE09}"/>
+              </a:ext>
+            </a:extLst>
+          </p:cNvPr>
+          <p:cNvSpPr txBox="1"/>
+          <p:nvPr/>
+        </p:nvSpPr>
+        <p:spPr>
+          <a:xfrm>
+            <a:off x="217714" y="144209"/>
+            <a:ext cx="11756571" cy="355354"/>
+          </a:xfrm>
+          <a:prstGeom prst="rect">
+            <a:avLst/>
+          </a:prstGeom>
+          <a:noFill/>
+        </p:spPr>
+        <p:txBody>
+          <a:bodyPr wrap="square">
+            <a:spAutoFit/>
+          </a:bodyPr>
+          <a:lstStyle/>
+          <a:p>
+            <a:pPr>
+              <a:lnSpc>
+                <a:spcPct val="150000"/>
+              </a:lnSpc>
+              <a:buNone/>
+            </a:pPr>
+            <a:r>
+              <a:rPr lang="az-Latn-AZ" altLang="en-US" sz="1300" b="1">
+                <a:latin typeface="Arial" panose="020B0604020202020204" pitchFamily="34" charset="0"/>
+              </a:rPr>
+              <a:t>A</a:t>
+            </a:r>
+            <a:r>
+              <a:rPr lang="az-Latn-AZ" altLang="en-US" sz="1300">
+                <a:latin typeface="Arial" panose="020B0604020202020204" pitchFamily="34" charset="0"/>
+              </a:rPr>
+              <a:t> elementinə kliklədikdə, </a:t>
+            </a:r>
+            <a:r>
+              <a:rPr lang="az-Latn-AZ" altLang="en-US" sz="1300" b="1">
+                <a:latin typeface="Arial" panose="020B0604020202020204" pitchFamily="34" charset="0"/>
+              </a:rPr>
+              <a:t>edit.blade.php </a:t>
+            </a:r>
+            <a:r>
+              <a:rPr lang="az-Latn-AZ" altLang="en-US" sz="1300">
+                <a:latin typeface="Arial" panose="020B0604020202020204" pitchFamily="34" charset="0"/>
+              </a:rPr>
+              <a:t>səhifəsini görüntüləmək üçün </a:t>
+            </a:r>
+            <a:r>
+              <a:rPr lang="az-Latn-AZ" altLang="en-US" sz="1300" b="1">
+                <a:latin typeface="Arial" panose="020B0604020202020204" pitchFamily="34" charset="0"/>
+              </a:rPr>
+              <a:t>route() </a:t>
+            </a:r>
+            <a:r>
+              <a:rPr lang="az-Latn-AZ" altLang="en-US" sz="1300">
+                <a:latin typeface="Arial" panose="020B0604020202020204" pitchFamily="34" charset="0"/>
+              </a:rPr>
+              <a:t>metoduna şəkildəki </a:t>
+            </a:r>
+            <a:r>
+              <a:rPr lang="az-Latn-AZ" altLang="en-US" sz="1300" b="1">
+                <a:latin typeface="Arial" panose="020B0604020202020204" pitchFamily="34" charset="0"/>
+              </a:rPr>
+              <a:t>name() </a:t>
+            </a:r>
+            <a:r>
+              <a:rPr lang="az-Latn-AZ" altLang="en-US" sz="1300">
+                <a:latin typeface="Arial" panose="020B0604020202020204" pitchFamily="34" charset="0"/>
+              </a:rPr>
+              <a:t>metodunun </a:t>
+            </a:r>
+            <a:r>
+              <a:rPr lang="az-Latn-AZ" altLang="en-US" sz="1300" b="1">
+                <a:latin typeface="Arial" panose="020B0604020202020204" pitchFamily="34" charset="0"/>
+              </a:rPr>
+              <a:t>dəyərini</a:t>
+            </a:r>
+            <a:r>
+              <a:rPr lang="az-Latn-AZ" altLang="en-US" sz="1300">
+                <a:latin typeface="Arial" panose="020B0604020202020204" pitchFamily="34" charset="0"/>
+              </a:rPr>
+              <a:t> -i əlavə edirik.</a:t>
+            </a:r>
+            <a:endParaRPr kumimoji="0" lang="en-US" altLang="en-US" sz="1300" b="0" i="0" u="none" strike="noStrike" cap="none" normalizeH="0" baseline="0">
+              <a:ln>
+                <a:noFill/>
+              </a:ln>
+              <a:solidFill>
+                <a:schemeClr val="tx1"/>
+              </a:solidFill>
+              <a:effectLst/>
+              <a:latin typeface="Arial" panose="020B0604020202020204" pitchFamily="34" charset="0"/>
+            </a:endParaRPr>
+          </a:p>
+        </p:txBody>
+      </p:sp>
+      <p:pic>
+        <p:nvPicPr>
+          <p:cNvPr id="4" name="Picture 3">
+            <a:extLst>
+              <a:ext uri="{FF2B5EF4-FFF2-40B4-BE49-F238E27FC236}">
+                <a16:creationId xmlns:a16="http://schemas.microsoft.com/office/drawing/2014/main" id="{6C083757-0003-0797-3CED-406E309BE714}"/>
+              </a:ext>
+            </a:extLst>
+          </p:cNvPr>
+          <p:cNvPicPr>
+            <a:picLocks noChangeAspect="1"/>
+          </p:cNvPicPr>
+          <p:nvPr/>
+        </p:nvPicPr>
+        <p:blipFill>
+          <a:blip r:embed="rId2"/>
+          <a:stretch>
+            <a:fillRect/>
+          </a:stretch>
+        </p:blipFill>
+        <p:spPr>
+          <a:xfrm>
+            <a:off x="748144" y="782264"/>
+            <a:ext cx="11443855" cy="6075735"/>
+          </a:xfrm>
+          <a:prstGeom prst="rect">
+            <a:avLst/>
+          </a:prstGeom>
+        </p:spPr>
+      </p:pic>
+    </p:spTree>
+    <p:extLst>
+      <p:ext uri="{BB962C8B-B14F-4D97-AF65-F5344CB8AC3E}">
+        <p14:creationId xmlns:p14="http://schemas.microsoft.com/office/powerpoint/2010/main" val="866903972"/>
+      </p:ext>
+    </p:extLst>
+  </p:cSld>
+  <p:clrMapOvr>
+    <a:masterClrMapping/>
+  </p:clrMapOvr>
+</p:sld>
+</file>
+
+<file path=ppt/slides/slide5.xml><?xml version="1.0" encoding="utf-8"?>
+<p:sld xmlns:a="http://schemas.openxmlformats.org/drawingml/2006/main" xmlns:r="http://schemas.openxmlformats.org/officeDocument/2006/relationships" xmlns:p="http://schemas.openxmlformats.org/presentationml/2006/main">
+  <p:cSld>
+    <p:spTree>
+      <p:nvGrpSpPr>
+        <p:cNvPr id="1" name="">
+          <a:extLst>
+            <a:ext uri="{FF2B5EF4-FFF2-40B4-BE49-F238E27FC236}">
+              <a16:creationId xmlns:a16="http://schemas.microsoft.com/office/drawing/2014/main" id="{CD799285-6D55-B64B-37B5-07F72C2D3EF1}"/>
+            </a:ext>
+          </a:extLst>
+        </p:cNvPr>
+        <p:cNvGrpSpPr/>
+        <p:nvPr/>
+      </p:nvGrpSpPr>
+      <p:grpSpPr>
+        <a:xfrm>
+          <a:off x="0" y="0"/>
+          <a:ext cx="0" cy="0"/>
+          <a:chOff x="0" y="0"/>
+          <a:chExt cx="0" cy="0"/>
+        </a:xfrm>
+      </p:grpSpPr>
+      <p:sp>
+        <p:nvSpPr>
+          <p:cNvPr id="3" name="TextBox 2">
+            <a:extLst>
+              <a:ext uri="{FF2B5EF4-FFF2-40B4-BE49-F238E27FC236}">
+                <a16:creationId xmlns:a16="http://schemas.microsoft.com/office/drawing/2014/main" id="{814AC11B-2677-A427-2E3D-A9DECAA7E88F}"/>
+              </a:ext>
+            </a:extLst>
+          </p:cNvPr>
+          <p:cNvSpPr txBox="1"/>
+          <p:nvPr/>
+        </p:nvSpPr>
+        <p:spPr>
+          <a:xfrm>
+            <a:off x="217714" y="255046"/>
+            <a:ext cx="11756571" cy="355354"/>
+          </a:xfrm>
+          <a:prstGeom prst="rect">
+            <a:avLst/>
+          </a:prstGeom>
+          <a:noFill/>
+        </p:spPr>
+        <p:txBody>
+          <a:bodyPr wrap="square">
+            <a:spAutoFit/>
+          </a:bodyPr>
+          <a:lstStyle/>
+          <a:p>
+            <a:pPr>
+              <a:lnSpc>
+                <a:spcPct val="150000"/>
+              </a:lnSpc>
+              <a:buNone/>
+            </a:pPr>
+            <a:r>
+              <a:rPr lang="en-US" altLang="en-US" sz="1300">
+                <a:latin typeface="Arial" panose="020B0604020202020204" pitchFamily="34" charset="0"/>
+              </a:rPr>
+              <a:t>Kodumuzu modifikasiya </a:t>
+            </a:r>
+            <a:r>
+              <a:rPr lang="az-Latn-AZ" altLang="en-US" sz="1300">
+                <a:latin typeface="Arial" panose="020B0604020202020204" pitchFamily="34" charset="0"/>
+              </a:rPr>
+              <a:t>edərək </a:t>
+            </a:r>
+            <a:r>
+              <a:rPr lang="az-Latn-AZ" altLang="en-US" sz="1300" b="1">
+                <a:latin typeface="Arial" panose="020B0604020202020204" pitchFamily="34" charset="0"/>
+              </a:rPr>
+              <a:t>DELETE</a:t>
+            </a:r>
+            <a:r>
+              <a:rPr lang="az-Latn-AZ" altLang="en-US" sz="1300">
+                <a:latin typeface="Arial" panose="020B0604020202020204" pitchFamily="34" charset="0"/>
+              </a:rPr>
+              <a:t> düyməsidə əlavə edirik.</a:t>
+            </a:r>
+            <a:endParaRPr kumimoji="0" lang="en-US" altLang="en-US" sz="1300" b="0" i="0" u="none" strike="noStrike" cap="none" normalizeH="0" baseline="0">
+              <a:ln>
+                <a:noFill/>
+              </a:ln>
+              <a:solidFill>
+                <a:schemeClr val="tx1"/>
+              </a:solidFill>
+              <a:effectLst/>
+              <a:latin typeface="Arial" panose="020B0604020202020204" pitchFamily="34" charset="0"/>
+            </a:endParaRPr>
+          </a:p>
+        </p:txBody>
+      </p:sp>
+      <p:pic>
+        <p:nvPicPr>
+          <p:cNvPr id="4" name="Picture 3">
+            <a:extLst>
+              <a:ext uri="{FF2B5EF4-FFF2-40B4-BE49-F238E27FC236}">
+                <a16:creationId xmlns:a16="http://schemas.microsoft.com/office/drawing/2014/main" id="{405C085A-CF38-6566-4DFB-411E4E30065C}"/>
+              </a:ext>
+            </a:extLst>
+          </p:cNvPr>
+          <p:cNvPicPr>
+            <a:picLocks noChangeAspect="1"/>
+          </p:cNvPicPr>
+          <p:nvPr/>
+        </p:nvPicPr>
+        <p:blipFill>
+          <a:blip r:embed="rId2"/>
+          <a:stretch>
+            <a:fillRect/>
+          </a:stretch>
+        </p:blipFill>
+        <p:spPr>
+          <a:xfrm>
+            <a:off x="1653308" y="1282982"/>
+            <a:ext cx="10538691" cy="5575018"/>
+          </a:xfrm>
+          <a:prstGeom prst="rect">
+            <a:avLst/>
+          </a:prstGeom>
+        </p:spPr>
+      </p:pic>
+    </p:spTree>
+    <p:extLst>
+      <p:ext uri="{BB962C8B-B14F-4D97-AF65-F5344CB8AC3E}">
+        <p14:creationId xmlns:p14="http://schemas.microsoft.com/office/powerpoint/2010/main" val="2669405190"/>
+      </p:ext>
+    </p:extLst>
+  </p:cSld>
+  <p:clrMapOvr>
+    <a:masterClrMapping/>
+  </p:clrMapOvr>
+</p:sld>
+</file>
+
+<file path=ppt/slides/slide6.xml><?xml version="1.0" encoding="utf-8"?>
+<p:sld xmlns:a="http://schemas.openxmlformats.org/drawingml/2006/main" xmlns:r="http://schemas.openxmlformats.org/officeDocument/2006/relationships" xmlns:p="http://schemas.openxmlformats.org/presentationml/2006/main">
+  <p:cSld>
+    <p:spTree>
+      <p:nvGrpSpPr>
+        <p:cNvPr id="1" name="">
+          <a:extLst>
+            <a:ext uri="{FF2B5EF4-FFF2-40B4-BE49-F238E27FC236}">
+              <a16:creationId xmlns:a16="http://schemas.microsoft.com/office/drawing/2014/main" id="{455E05D3-77F6-A14A-D0B0-3085B9D6BB79}"/>
+            </a:ext>
+          </a:extLst>
+        </p:cNvPr>
+        <p:cNvGrpSpPr/>
+        <p:nvPr/>
+      </p:nvGrpSpPr>
+      <p:grpSpPr>
+        <a:xfrm>
+          <a:off x="0" y="0"/>
+          <a:ext cx="0" cy="0"/>
+          <a:chOff x="0" y="0"/>
+          <a:chExt cx="0" cy="0"/>
+        </a:xfrm>
+      </p:grpSpPr>
+      <p:sp>
+        <p:nvSpPr>
+          <p:cNvPr id="3" name="TextBox 2">
+            <a:extLst>
+              <a:ext uri="{FF2B5EF4-FFF2-40B4-BE49-F238E27FC236}">
+                <a16:creationId xmlns:a16="http://schemas.microsoft.com/office/drawing/2014/main" id="{A39BAFBB-2810-3786-FDA9-49DE858F1D82}"/>
+              </a:ext>
+            </a:extLst>
+          </p:cNvPr>
+          <p:cNvSpPr txBox="1"/>
+          <p:nvPr/>
+        </p:nvSpPr>
+        <p:spPr>
+          <a:xfrm>
+            <a:off x="217714" y="125736"/>
+            <a:ext cx="11756571" cy="355354"/>
+          </a:xfrm>
+          <a:prstGeom prst="rect">
+            <a:avLst/>
+          </a:prstGeom>
+          <a:noFill/>
+        </p:spPr>
+        <p:txBody>
+          <a:bodyPr wrap="square">
+            <a:spAutoFit/>
+          </a:bodyPr>
+          <a:lstStyle/>
+          <a:p>
+            <a:pPr>
+              <a:lnSpc>
+                <a:spcPct val="150000"/>
+              </a:lnSpc>
+              <a:buNone/>
+            </a:pPr>
+            <a:r>
+              <a:rPr lang="az-Latn-AZ" altLang="en-US" sz="1300">
+                <a:latin typeface="Arial" panose="020B0604020202020204" pitchFamily="34" charset="0"/>
+              </a:rPr>
+              <a:t>Nəticə.</a:t>
+            </a:r>
+            <a:endParaRPr kumimoji="0" lang="en-US" altLang="en-US" sz="1300" b="0" i="0" u="none" strike="noStrike" cap="none" normalizeH="0" baseline="0">
+              <a:ln>
+                <a:noFill/>
+              </a:ln>
+              <a:solidFill>
+                <a:schemeClr val="tx1"/>
+              </a:solidFill>
+              <a:effectLst/>
+              <a:latin typeface="Arial" panose="020B0604020202020204" pitchFamily="34" charset="0"/>
+            </a:endParaRPr>
+          </a:p>
+        </p:txBody>
+      </p:sp>
+      <p:pic>
+        <p:nvPicPr>
+          <p:cNvPr id="4" name="Picture 3">
+            <a:extLst>
+              <a:ext uri="{FF2B5EF4-FFF2-40B4-BE49-F238E27FC236}">
+                <a16:creationId xmlns:a16="http://schemas.microsoft.com/office/drawing/2014/main" id="{C7526B5C-F932-F015-8009-F40F82F97474}"/>
+              </a:ext>
+            </a:extLst>
+          </p:cNvPr>
+          <p:cNvPicPr>
+            <a:picLocks noChangeAspect="1"/>
+          </p:cNvPicPr>
+          <p:nvPr/>
+        </p:nvPicPr>
+        <p:blipFill>
+          <a:blip r:embed="rId2"/>
+          <a:stretch>
+            <a:fillRect/>
+          </a:stretch>
+        </p:blipFill>
+        <p:spPr>
+          <a:xfrm>
+            <a:off x="0" y="552668"/>
+            <a:ext cx="12192000" cy="6305332"/>
+          </a:xfrm>
+          <a:prstGeom prst="rect">
+            <a:avLst/>
+          </a:prstGeom>
+        </p:spPr>
+      </p:pic>
+    </p:spTree>
+    <p:extLst>
+      <p:ext uri="{BB962C8B-B14F-4D97-AF65-F5344CB8AC3E}">
+        <p14:creationId xmlns:p14="http://schemas.microsoft.com/office/powerpoint/2010/main" val="1494623751"/>
+      </p:ext>
+    </p:extLst>
+  </p:cSld>
+  <p:clrMapOvr>
+    <a:masterClrMapping/>
+  </p:clrMapOvr>
+</p:sld>
+</file>
+
+<file path=ppt/slides/slide7.xml><?xml version="1.0" encoding="utf-8"?>
+<p:sld xmlns:a="http://schemas.openxmlformats.org/drawingml/2006/main" xmlns:r="http://schemas.openxmlformats.org/officeDocument/2006/relationships" xmlns:p="http://schemas.openxmlformats.org/presentationml/2006/main">
+  <p:cSld>
+    <p:spTree>
+      <p:nvGrpSpPr>
+        <p:cNvPr id="1" name="">
+          <a:extLst>
+            <a:ext uri="{FF2B5EF4-FFF2-40B4-BE49-F238E27FC236}">
+              <a16:creationId xmlns:a16="http://schemas.microsoft.com/office/drawing/2014/main" id="{9A2EE537-5E8F-252D-577B-83ED8692269B}"/>
+            </a:ext>
+          </a:extLst>
+        </p:cNvPr>
+        <p:cNvGrpSpPr/>
+        <p:nvPr/>
+      </p:nvGrpSpPr>
+      <p:grpSpPr>
+        <a:xfrm>
+          <a:off x="0" y="0"/>
+          <a:ext cx="0" cy="0"/>
+          <a:chOff x="0" y="0"/>
+          <a:chExt cx="0" cy="0"/>
+        </a:xfrm>
+      </p:grpSpPr>
+      <p:sp>
+        <p:nvSpPr>
+          <p:cNvPr id="3" name="TextBox 2">
+            <a:extLst>
+              <a:ext uri="{FF2B5EF4-FFF2-40B4-BE49-F238E27FC236}">
+                <a16:creationId xmlns:a16="http://schemas.microsoft.com/office/drawing/2014/main" id="{42AEC7A9-FAD7-0D0E-90B3-C656BE6B9992}"/>
+              </a:ext>
+            </a:extLst>
+          </p:cNvPr>
+          <p:cNvSpPr txBox="1"/>
+          <p:nvPr/>
+        </p:nvSpPr>
+        <p:spPr>
+          <a:xfrm>
+            <a:off x="217714" y="255046"/>
+            <a:ext cx="11756571" cy="355354"/>
+          </a:xfrm>
+          <a:prstGeom prst="rect">
+            <a:avLst/>
+          </a:prstGeom>
+          <a:noFill/>
+        </p:spPr>
+        <p:txBody>
+          <a:bodyPr wrap="square">
+            <a:spAutoFit/>
+          </a:bodyPr>
+          <a:lstStyle/>
+          <a:p>
+            <a:pPr>
+              <a:lnSpc>
+                <a:spcPct val="150000"/>
+              </a:lnSpc>
+              <a:buNone/>
+            </a:pPr>
+            <a:r>
+              <a:rPr kumimoji="0" lang="en-US" altLang="en-US" sz="1300" b="0" i="0" u="none" strike="noStrike" cap="none" normalizeH="0" baseline="0">
+                <a:ln>
+                  <a:noFill/>
+                </a:ln>
+                <a:solidFill>
+                  <a:schemeClr val="tx1"/>
+                </a:solidFill>
+                <a:effectLst/>
+                <a:latin typeface="Arial" panose="020B0604020202020204" pitchFamily="34" charset="0"/>
+              </a:rPr>
+              <a:t>.</a:t>
+            </a:r>
+          </a:p>
+        </p:txBody>
+      </p:sp>
+    </p:spTree>
+    <p:extLst>
+      <p:ext uri="{BB962C8B-B14F-4D97-AF65-F5344CB8AC3E}">
+        <p14:creationId xmlns:p14="http://schemas.microsoft.com/office/powerpoint/2010/main" val="2802361049"/>
+      </p:ext>
+    </p:extLst>
+  </p:cSld>
+  <p:clrMapOvr>
+    <a:masterClrMapping/>
+  </p:clrMapOvr>
+</p:sld>
+</file>
+
+<file path=ppt/slides/slide8.xml><?xml version="1.0" encoding="utf-8"?>
 <p:sld xmlns:a="http://schemas.openxmlformats.org/drawingml/2006/main" xmlns:r="http://schemas.openxmlformats.org/officeDocument/2006/relationships" xmlns:p="http://schemas.openxmlformats.org/presentationml/2006/main">
   <p:cSld>
     <p:spTree>

</xml_diff>